<commit_message>
Add agenda slide (slide 2) to CRANE AI-Cyber SIG presentation
</commit_message>
<xml_diff>
--- a/SABRE_CRANE_SIG_2026.pptx
+++ b/SABRE_CRANE_SIG_2026.pptx
@@ -6,6 +6,7 @@
   </p:sldMasterIdLst>
   <p:sldIdLst>
     <p:sldId id="256" r:id="rId2"/>
+    <p:sldId id="264" r:id="rId15"/>
     <p:sldId id="257" r:id="rId3"/>
     <p:sldId id="258" r:id="rId4"/>
     <p:sldId id="259" r:id="rId5"/>
@@ -6093,7 +6094,7 @@
                 </a:solidFill>
                 <a:latin typeface="Aptos Display"/>
               </a:rPr>
-              <a:t>Since This Abstract: SABRE-II — Learned Fusion &amp; Policy</a:t>
+              <a:t>SABRE-II: Learned Fusion &amp; Bayesian Policy</a:t>
             </a:r>
             <a:endParaRPr lang="en-GB" sz="4200"/>
           </a:p>
@@ -7796,6 +7797,324 @@
         <p14:creationId xmlns:p14="http://schemas.microsoft.com/office/powerpoint/2010/main" val="1970056675"/>
       </p:ext>
     </p:extLst>
+  </p:cSld>
+  <p:clrMapOvr>
+    <a:masterClrMapping/>
+  </p:clrMapOvr>
+</p:sld>
+</file>
+
+<file path=ppt/slides/slide9.xml><?xml version="1.0" encoding="utf-8"?>
+<p:sld xmlns:a="http://schemas.openxmlformats.org/drawingml/2006/main" xmlns:p="http://schemas.openxmlformats.org/presentationml/2006/main" xmlns:r="http://schemas.openxmlformats.org/officeDocument/2006/relationships">
+  <p:cSld>
+    <p:spTree>
+      <p:nvGrpSpPr>
+        <p:cNvPr id="1" name=""/>
+        <p:cNvGrpSpPr/>
+        <p:nvPr/>
+      </p:nvGrpSpPr>
+      <p:grpSpPr/>
+      <p:cxnSp>
+        <p:nvCxnSpPr>
+          <p:cNvPr id="4" name="Straight Connector 3">
+            <a:extLst>
+              <a:ext uri="{FF2B5EF4-FFF2-40B4-BE49-F238E27FC236}">
+                <a16:creationId xmlns:a16="http://schemas.microsoft.com/office/drawing/2014/main" id="{F04E40D7-BE15-03B3-6F32-D4894228A3A0}"/>
+              </a:ext>
+            </a:extLst>
+          </p:cNvPr>
+          <p:cNvCxnSpPr/>
+          <p:nvPr/>
+        </p:nvCxnSpPr>
+        <p:spPr>
+          <a:xfrm>
+            <a:off x="196788" y="1364942"/>
+            <a:ext cx="11798423" cy="0"/>
+          </a:xfrm>
+          <a:prstGeom prst="line">
+            <a:avLst/>
+          </a:prstGeom>
+        </p:spPr>
+        <p:style>
+          <a:lnRef idx="2">
+            <a:schemeClr val="accent1"/>
+          </a:lnRef>
+          <a:fillRef idx="0">
+            <a:schemeClr val="accent1"/>
+          </a:fillRef>
+          <a:effectRef idx="1">
+            <a:schemeClr val="accent1"/>
+          </a:effectRef>
+          <a:fontRef idx="minor">
+            <a:schemeClr val="tx1"/>
+          </a:fontRef>
+        </p:style>
+      </p:cxnSp>
+      <p:sp>
+        <p:nvSpPr>
+          <p:cNvPr id="3" name="Content Placeholder 2">
+            <a:extLst>
+              <a:ext uri="{FF2B5EF4-FFF2-40B4-BE49-F238E27FC236}">
+                <a16:creationId xmlns:a16="http://schemas.microsoft.com/office/drawing/2014/main" id="{BA919012-1158-CC85-7281-8334EED33B59}"/>
+              </a:ext>
+            </a:extLst>
+          </p:cNvPr>
+          <p:cNvSpPr>
+            <a:spLocks noGrp="1"/>
+          </p:cNvSpPr>
+          <p:nvPr>
+            <p:ph idx="1"/>
+          </p:nvPr>
+        </p:nvSpPr>
+        <p:spPr/>
+        <p:txBody>
+          <a:bodyPr vert="horz" lIns="91440" tIns="45720" rIns="91440" bIns="45720" rtlCol="0" anchor="t">
+            <a:normAutofit/>
+          </a:bodyPr>
+          <a:lstStyle/>
+          <a:p>
+            <a:pPr lvl="1">
+              <a:spcBef>
+                <a:spcPts val="400"/>
+              </a:spcBef>
+              <a:buClr>
+                <a:srgbClr val="E97132"/>
+              </a:buClr>
+              <a:buFont typeface="Arial"/>
+              <a:buChar char="▸"/>
+            </a:pPr>
+            <a:r>
+              <a:rPr lang="en-GB" sz="1800" b="0" dirty="0">
+                <a:latin typeface="Aptos"/>
+                <a:solidFill>
+                  <a:srgbClr val="0E2841"/>
+                </a:solidFill>
+              </a:rPr>
+              <a:t>The Problem — why binary detection fails in practice</a:t>
+            </a:r>
+          </a:p>
+          <a:p>
+            <a:pPr lvl="1">
+              <a:spcBef>
+                <a:spcPts val="400"/>
+              </a:spcBef>
+              <a:buClr>
+                <a:srgbClr val="E97132"/>
+              </a:buClr>
+              <a:buFont typeface="Arial"/>
+              <a:buChar char="▸"/>
+            </a:pPr>
+            <a:r>
+              <a:rPr lang="en-GB" sz="1800" b="0" dirty="0">
+                <a:latin typeface="Aptos"/>
+                <a:solidFill>
+                  <a:srgbClr val="0E2841"/>
+                </a:solidFill>
+              </a:rPr>
+              <a:t>SABRE Architecture — two complementary detection agents</a:t>
+            </a:r>
+          </a:p>
+          <a:p>
+            <a:pPr lvl="1">
+              <a:spcBef>
+                <a:spcPts val="400"/>
+              </a:spcBef>
+              <a:buClr>
+                <a:srgbClr val="E97132"/>
+              </a:buClr>
+              <a:buFont typeface="Arial"/>
+              <a:buChar char="▸"/>
+            </a:pPr>
+            <a:r>
+              <a:rPr lang="en-GB" sz="1800" b="0" dirty="0">
+                <a:latin typeface="Aptos"/>
+                <a:solidFill>
+                  <a:srgbClr val="0E2841"/>
+                </a:solidFill>
+              </a:rPr>
+              <a:t>Triage Policy — operationalising uncertainty as a control variable</a:t>
+            </a:r>
+          </a:p>
+          <a:p>
+            <a:pPr lvl="1">
+              <a:spcBef>
+                <a:spcPts val="400"/>
+              </a:spcBef>
+              <a:buClr>
+                <a:srgbClr val="E97132"/>
+              </a:buClr>
+              <a:buFont typeface="Arial"/>
+              <a:buChar char="▸"/>
+            </a:pPr>
+            <a:r>
+              <a:rPr lang="en-GB" sz="1800" b="0" dirty="0">
+                <a:latin typeface="Aptos"/>
+                <a:solidFill>
+                  <a:srgbClr val="0E2841"/>
+                </a:solidFill>
+              </a:rPr>
+              <a:t>Results — where SABRE works and where it struggles</a:t>
+            </a:r>
+          </a:p>
+          <a:p>
+            <a:pPr lvl="1">
+              <a:spcBef>
+                <a:spcPts val="400"/>
+              </a:spcBef>
+              <a:buClr>
+                <a:srgbClr val="E97132"/>
+              </a:buClr>
+              <a:buFont typeface="Arial"/>
+              <a:buChar char="▸"/>
+            </a:pPr>
+            <a:r>
+              <a:rPr lang="en-GB" sz="1800" b="0" dirty="0">
+                <a:latin typeface="Aptos"/>
+                <a:solidFill>
+                  <a:srgbClr val="0E2841"/>
+                </a:solidFill>
+              </a:rPr>
+              <a:t>Explainability — making decisions auditable</a:t>
+            </a:r>
+          </a:p>
+          <a:p>
+            <a:pPr lvl="1">
+              <a:spcBef>
+                <a:spcPts val="400"/>
+              </a:spcBef>
+              <a:buClr>
+                <a:srgbClr val="E97132"/>
+              </a:buClr>
+              <a:buFont typeface="Arial"/>
+              <a:buChar char="▸"/>
+            </a:pPr>
+            <a:r>
+              <a:rPr lang="en-GB" sz="1800" b="0" dirty="0">
+                <a:latin typeface="Aptos"/>
+                <a:solidFill>
+                  <a:srgbClr val="0E2841"/>
+                </a:solidFill>
+              </a:rPr>
+              <a:t>SABRE-II — learned fusion and Bayesian policy optimisation</a:t>
+            </a:r>
+          </a:p>
+          <a:p>
+            <a:pPr lvl="1">
+              <a:spcBef>
+                <a:spcPts val="400"/>
+              </a:spcBef>
+              <a:buClr>
+                <a:srgbClr val="E97132"/>
+              </a:buClr>
+              <a:buFont typeface="Arial"/>
+              <a:buChar char="▸"/>
+            </a:pPr>
+            <a:r>
+              <a:rPr lang="en-GB" sz="1800" b="0" dirty="0">
+                <a:latin typeface="Aptos"/>
+                <a:solidFill>
+                  <a:srgbClr val="0E2841"/>
+                </a:solidFill>
+              </a:rPr>
+              <a:t>Conclusions &amp; Discussion</a:t>
+            </a:r>
+          </a:p>
+          <a:p>
+            <a:pPr>
+              <a:buNone/>
+            </a:pPr>
+            <a:r>
+              <a:rPr lang="en-GB" sz="600" b="0" dirty="0">
+                <a:latin typeface="Aptos"/>
+              </a:rPr>
+              <a:t/>
+            </a:r>
+          </a:p>
+          <a:p>
+            <a:pPr algn="ctr">
+              <a:buNone/>
+            </a:pPr>
+            <a:r>
+              <a:rPr lang="en-GB" sz="1500" b="0" dirty="0">
+                <a:latin typeface="Aptos"/>
+                <a:solidFill>
+                  <a:srgbClr val="156082"/>
+                </a:solidFill>
+              </a:rPr>
+              <a:t>15 min talk · 5 min Q&amp;A</a:t>
+            </a:r>
+          </a:p>
+        </p:txBody>
+      </p:sp>
+      <p:sp>
+        <p:nvSpPr>
+          <p:cNvPr id="2" name="Title 1">
+            <a:extLst>
+              <a:ext uri="{FF2B5EF4-FFF2-40B4-BE49-F238E27FC236}">
+                <a16:creationId xmlns:a16="http://schemas.microsoft.com/office/drawing/2014/main" id="{8C7BA404-C596-C471-3B59-87E69A4BB8A7}"/>
+              </a:ext>
+            </a:extLst>
+          </p:cNvPr>
+          <p:cNvSpPr>
+            <a:spLocks noGrp="1"/>
+          </p:cNvSpPr>
+          <p:nvPr>
+            <p:ph type="title"/>
+          </p:nvPr>
+        </p:nvSpPr>
+        <p:spPr/>
+        <p:txBody>
+          <a:bodyPr/>
+          <a:lstStyle/>
+          <a:p>
+            <a:r>
+              <a:rPr sz="2800" b="1">
+                <a:solidFill>
+                  <a:srgbClr val="0E2841"/>
+                </a:solidFill>
+                <a:latin typeface="Aptos Display"/>
+              </a:rPr>
+              <a:t>Agenda</a:t>
+            </a:r>
+            <a:endParaRPr lang="en-GB" err="1"/>
+          </a:p>
+        </p:txBody>
+      </p:sp>
+      <p:sp>
+        <p:nvSpPr>
+          <p:cNvPr id="2" name="Title 1"/>
+          <p:cNvSpPr>
+            <a:spLocks noGrp="1"/>
+          </p:cNvSpPr>
+          <p:nvPr>
+            <p:ph type="title"/>
+          </p:nvPr>
+        </p:nvSpPr>
+        <p:spPr/>
+        <p:txBody>
+          <a:bodyPr/>
+          <a:lstStyle/>
+          <a:p/>
+        </p:txBody>
+      </p:sp>
+      <p:sp>
+        <p:nvSpPr>
+          <p:cNvPr id="3" name="Content Placeholder 2"/>
+          <p:cNvSpPr>
+            <a:spLocks noGrp="1"/>
+          </p:cNvSpPr>
+          <p:nvPr>
+            <p:ph idx="1"/>
+          </p:nvPr>
+        </p:nvSpPr>
+        <p:spPr/>
+        <p:txBody>
+          <a:bodyPr/>
+          <a:lstStyle/>
+          <a:p/>
+        </p:txBody>
+      </p:sp>
+    </p:spTree>
   </p:cSld>
   <p:clrMapOvr>
     <a:masterClrMapping/>

</xml_diff>

<commit_message>
Add counterfactual explanation figures to explainability slide
</commit_message>
<xml_diff>
--- a/SABRE_CRANE_SIG_2026.pptx
+++ b/SABRE_CRANE_SIG_2026.pptx
@@ -5783,9 +5783,146 @@
           </a:p>
         </p:txBody>
       </p:sp>
+      <p:sp>
+        <p:nvSpPr>
+          <p:cNvPr id="7" name="TextBox 6"/>
+          <p:cNvSpPr txBox="1"/>
+          <p:nvPr/>
+        </p:nvSpPr>
+        <p:spPr>
+          <a:xfrm>
+            <a:off x="457200" y="1188720"/>
+            <a:ext cx="5303520" cy="2286000"/>
+          </a:xfrm>
+          <a:prstGeom prst="rect">
+            <a:avLst/>
+          </a:prstGeom>
+          <a:noFill/>
+        </p:spPr>
+        <p:txBody>
+          <a:bodyPr wrap="square">
+            <a:spAutoFit/>
+          </a:bodyPr>
+          <a:lstStyle/>
+          <a:p>
+            <a:pPr>
+              <a:buNone/>
+            </a:pPr>
+            <a:r>
+              <a:rPr lang="en-GB" sz="1500" b="1" dirty="0">
+                <a:latin typeface="Aptos"/>
+                <a:solidFill>
+                  <a:srgbClr val="0E2841"/>
+                </a:solidFill>
+              </a:rPr>
+              <a:t>Feature Importance (Behavioural):</a:t>
+            </a:r>
+          </a:p>
+          <a:p>
+            <a:pPr lvl="1">
+              <a:buClr>
+                <a:srgbClr val="E97132"/>
+              </a:buClr>
+              <a:buFont typeface="Arial"/>
+              <a:buChar char="▸"/>
+            </a:pPr>
+            <a:r>
+              <a:rPr lang="en-GB" sz="1400" b="0" dirty="0">
+                <a:latin typeface="Aptos"/>
+              </a:rPr>
+              <a:t>write_entropy_mean: encryption → max entropy</a:t>
+            </a:r>
+          </a:p>
+          <a:p>
+            <a:pPr lvl="1">
+              <a:buClr>
+                <a:srgbClr val="E97132"/>
+              </a:buClr>
+              <a:buFont typeface="Arial"/>
+              <a:buChar char="▸"/>
+            </a:pPr>
+            <a:r>
+              <a:rPr lang="en-GB" sz="1400" b="0" dirty="0">
+                <a:latin typeface="Aptos"/>
+              </a:rPr>
+              <a:t>write_LBA_variance: sequential full-disk writes</a:t>
+            </a:r>
+          </a:p>
+          <a:p>
+            <a:pPr lvl="1">
+              <a:buClr>
+                <a:srgbClr val="E97132"/>
+              </a:buClr>
+              <a:buFont typeface="Arial"/>
+              <a:buChar char="▸"/>
+            </a:pPr>
+            <a:r>
+              <a:rPr lang="en-GB" sz="1400" b="0" dirty="0">
+                <a:latin typeface="Aptos"/>
+              </a:rPr>
+              <a:t>mem_write_GPA_variance: uniform memory spread</a:t>
+            </a:r>
+          </a:p>
+          <a:p>
+            <a:pPr>
+              <a:buNone/>
+            </a:pPr>
+            <a:r>
+              <a:rPr lang="en-GB" sz="400" b="0" dirty="0">
+                <a:latin typeface="Aptos"/>
+              </a:rPr>
+              <a:t/>
+            </a:r>
+          </a:p>
+          <a:p>
+            <a:pPr>
+              <a:buNone/>
+            </a:pPr>
+            <a:r>
+              <a:rPr lang="en-GB" sz="1500" b="1" dirty="0">
+                <a:latin typeface="Aptos"/>
+                <a:solidFill>
+                  <a:srgbClr val="0E2841"/>
+                </a:solidFill>
+              </a:rPr>
+              <a:t>Counterfactual Explanations:</a:t>
+            </a:r>
+          </a:p>
+          <a:p>
+            <a:pPr lvl="1">
+              <a:buClr>
+                <a:srgbClr val="E97132"/>
+              </a:buClr>
+              <a:buFont typeface="Arial"/>
+              <a:buChar char="▸"/>
+            </a:pPr>
+            <a:r>
+              <a:rPr lang="en-GB" sz="1400" b="0" dirty="0">
+                <a:latin typeface="Aptos"/>
+              </a:rPr>
+              <a:t>Minimal L₂ shift flips verdict → analyst sees exactly WHY</a:t>
+            </a:r>
+          </a:p>
+          <a:p>
+            <a:pPr lvl="1">
+              <a:buClr>
+                <a:srgbClr val="E97132"/>
+              </a:buClr>
+              <a:buFont typeface="Arial"/>
+              <a:buChar char="▸"/>
+            </a:pPr>
+            <a:r>
+              <a:rPr lang="en-GB" sz="1400" b="0" dirty="0">
+                <a:latin typeface="Aptos"/>
+              </a:rPr>
+              <a:t>Short distance → near decision boundary → ESCALATE</a:t>
+            </a:r>
+          </a:p>
+        </p:txBody>
+      </p:sp>
       <p:pic>
         <p:nvPicPr>
-          <p:cNvPr id="7" name="Picture 6" descr="Behaviour_feature_importance.png"/>
+          <p:cNvPr id="8" name="Picture 7" descr="Behaviour_feature_importance.png"/>
           <p:cNvPicPr>
             <a:picLocks noChangeAspect="1"/>
           </p:cNvPicPr>
@@ -5799,236 +5936,62 @@
         </p:blipFill>
         <p:spPr>
           <a:xfrm>
-            <a:off x="6217920" y="1188720"/>
-            <a:ext cx="5486400" cy="2743200"/>
+            <a:off x="5852160" y="1143000"/>
+            <a:ext cx="6126480" cy="2377440"/>
           </a:xfrm>
           <a:prstGeom prst="rect">
             <a:avLst/>
           </a:prstGeom>
         </p:spPr>
       </p:pic>
-      <p:sp>
-        <p:nvSpPr>
-          <p:cNvPr id="8" name="TextBox 7"/>
-          <p:cNvSpPr txBox="1"/>
+      <p:pic>
+        <p:nvPicPr>
+          <p:cNvPr id="9" name="Picture 8" descr="Rep_Beh_CFs.png"/>
+          <p:cNvPicPr>
+            <a:picLocks noChangeAspect="1"/>
+          </p:cNvPicPr>
           <p:nvPr/>
-        </p:nvSpPr>
+        </p:nvPicPr>
+        <p:blipFill>
+          <a:blip r:embed="rId3"/>
+          <a:stretch>
+            <a:fillRect/>
+          </a:stretch>
+        </p:blipFill>
         <p:spPr>
           <a:xfrm>
-            <a:off x="548640" y="1188720"/>
-            <a:ext cx="5486400" cy="5303520"/>
+            <a:off x="457200" y="3749039"/>
+            <a:ext cx="5394960" cy="2834640"/>
           </a:xfrm>
           <a:prstGeom prst="rect">
             <a:avLst/>
           </a:prstGeom>
-          <a:noFill/>
         </p:spPr>
-        <p:txBody>
-          <a:bodyPr wrap="square">
-            <a:spAutoFit/>
-          </a:bodyPr>
-          <a:lstStyle/>
-          <a:p>
-            <a:pPr>
-              <a:buNone/>
-            </a:pPr>
-            <a:r>
-              <a:rPr lang="en-GB" sz="1700" b="1" dirty="0">
-                <a:latin typeface="Aptos"/>
-                <a:solidFill>
-                  <a:srgbClr val="0E2841"/>
-                </a:solidFill>
-              </a:rPr>
-              <a:t>Behavioural — Permutation Feature Importance:</a:t>
-            </a:r>
-          </a:p>
-          <a:p>
-            <a:pPr lvl="1">
-              <a:buClr>
-                <a:srgbClr val="E97132"/>
-              </a:buClr>
-              <a:buFont typeface="Arial"/>
-              <a:buChar char="▸"/>
-            </a:pPr>
-            <a:r>
-              <a:rPr lang="en-GB" sz="1600" b="0" dirty="0">
-                <a:latin typeface="Aptos"/>
-              </a:rPr>
-              <a:t>write_entropy_mean: top driver — ransomware encrypts → max entropy</a:t>
-            </a:r>
-          </a:p>
-          <a:p>
-            <a:pPr lvl="1">
-              <a:buClr>
-                <a:srgbClr val="E97132"/>
-              </a:buClr>
-              <a:buFont typeface="Arial"/>
-              <a:buChar char="▸"/>
-            </a:pPr>
-            <a:r>
-              <a:rPr lang="en-GB" sz="1600" b="0" dirty="0">
-                <a:latin typeface="Aptos"/>
-              </a:rPr>
-              <a:t>write_LBA_variance: sequential writes across entire disk</a:t>
-            </a:r>
-          </a:p>
-          <a:p>
-            <a:pPr lvl="1">
-              <a:buClr>
-                <a:srgbClr val="E97132"/>
-              </a:buClr>
-              <a:buFont typeface="Arial"/>
-              <a:buChar char="▸"/>
-            </a:pPr>
-            <a:r>
-              <a:rPr lang="en-GB" sz="1600" b="0" dirty="0">
-                <a:latin typeface="Aptos"/>
-              </a:rPr>
-              <a:t>mem_write_GPA_variance: broad memory pages written uniformly</a:t>
-            </a:r>
-          </a:p>
-          <a:p>
-            <a:pPr>
-              <a:buNone/>
-            </a:pPr>
-            <a:r>
-              <a:rPr lang="en-GB" sz="600" b="0" dirty="0">
-                <a:latin typeface="Aptos"/>
-              </a:rPr>
-              <a:t/>
-            </a:r>
-          </a:p>
-          <a:p>
-            <a:pPr>
-              <a:buNone/>
-            </a:pPr>
-            <a:r>
-              <a:rPr lang="en-GB" sz="1700" b="1" dirty="0">
-                <a:latin typeface="Aptos"/>
-                <a:solidFill>
-                  <a:srgbClr val="0E2841"/>
-                </a:solidFill>
-              </a:rPr>
-              <a:t>Semantic — Counterfactual Diagnostics:</a:t>
-            </a:r>
-          </a:p>
-          <a:p>
-            <a:pPr lvl="1">
-              <a:buClr>
-                <a:srgbClr val="E97132"/>
-              </a:buClr>
-              <a:buFont typeface="Arial"/>
-              <a:buChar char="▸"/>
-            </a:pPr>
-            <a:r>
-              <a:rPr lang="en-GB" sz="1600" b="0" dirty="0">
-                <a:latin typeface="Aptos"/>
-              </a:rPr>
-              <a:t>For borderline PE files: minimal embedding shift to flip verdict</a:t>
-            </a:r>
-          </a:p>
-          <a:p>
-            <a:pPr lvl="1">
-              <a:buClr>
-                <a:srgbClr val="E97132"/>
-              </a:buClr>
-              <a:buFont typeface="Arial"/>
-              <a:buChar char="▸"/>
-            </a:pPr>
-            <a:r>
-              <a:rPr lang="en-GB" sz="1600" b="0" dirty="0">
-                <a:latin typeface="Aptos"/>
-              </a:rPr>
-              <a:t>Short L₂ distance → closer to decision boundary → escalate</a:t>
-            </a:r>
-          </a:p>
-          <a:p>
-            <a:pPr lvl="1">
-              <a:buClr>
-                <a:srgbClr val="E97132"/>
-              </a:buClr>
-              <a:buFont typeface="Arial"/>
-              <a:buChar char="▸"/>
-            </a:pPr>
-            <a:r>
-              <a:rPr lang="en-GB" sz="1600" b="0" dirty="0">
-                <a:latin typeface="Aptos"/>
-              </a:rPr>
-              <a:t>Supports audit: 'why was this file flagged?'</a:t>
-            </a:r>
-          </a:p>
-          <a:p>
-            <a:pPr>
-              <a:buNone/>
-            </a:pPr>
-            <a:r>
-              <a:rPr lang="en-GB" sz="600" b="0" dirty="0">
-                <a:latin typeface="Aptos"/>
-              </a:rPr>
-              <a:t/>
-            </a:r>
-          </a:p>
-          <a:p>
-            <a:pPr>
-              <a:buNone/>
-            </a:pPr>
-            <a:r>
-              <a:rPr lang="en-GB" sz="1700" b="1" dirty="0">
-                <a:latin typeface="Aptos"/>
-                <a:solidFill>
-                  <a:srgbClr val="E97132"/>
-                </a:solidFill>
-              </a:rPr>
-              <a:t>On Reviewer 3's question — current operational practice:</a:t>
-            </a:r>
-          </a:p>
-          <a:p>
-            <a:pPr lvl="1">
-              <a:buClr>
-                <a:srgbClr val="E97132"/>
-              </a:buClr>
-              <a:buFont typeface="Arial"/>
-              <a:buChar char="▸"/>
-            </a:pPr>
-            <a:r>
-              <a:rPr lang="en-GB" sz="1600" b="0" dirty="0">
-                <a:latin typeface="Aptos"/>
-              </a:rPr>
-              <a:t>Antivirus/EDR: threshold-based scores, no principled uncertainty</a:t>
-            </a:r>
-          </a:p>
-          <a:p>
-            <a:pPr lvl="1">
-              <a:buClr>
-                <a:srgbClr val="E97132"/>
-              </a:buClr>
-              <a:buFont typeface="Arial"/>
-              <a:buChar char="▸"/>
-            </a:pPr>
-            <a:r>
-              <a:rPr lang="en-GB" sz="1600" b="0" dirty="0">
-                <a:latin typeface="Aptos"/>
-              </a:rPr>
-              <a:t>SABRE adds: σ as a first-class decision variable + XAI audit trail</a:t>
-            </a:r>
-          </a:p>
-          <a:p>
-            <a:pPr lvl="1">
-              <a:buClr>
-                <a:srgbClr val="E97132"/>
-              </a:buClr>
-              <a:buFont typeface="Arial"/>
-              <a:buChar char="▸"/>
-            </a:pPr>
-            <a:r>
-              <a:rPr lang="en-GB" sz="1600" b="0" dirty="0">
-                <a:latin typeface="Aptos"/>
-              </a:rPr>
-              <a:t>Analyst can see WHY a sample was escalated, not just THAT it was</a:t>
-            </a:r>
-          </a:p>
-        </p:txBody>
-      </p:sp>
+      </p:pic>
+      <p:pic>
+        <p:nvPicPr>
+          <p:cNvPr id="10" name="Picture 9" descr="fig_semantic_cf_p0_vs_l2.png"/>
+          <p:cNvPicPr>
+            <a:picLocks noChangeAspect="1"/>
+          </p:cNvPicPr>
+          <p:nvPr/>
+        </p:nvPicPr>
+        <p:blipFill>
+          <a:blip r:embed="rId4"/>
+          <a:stretch>
+            <a:fillRect/>
+          </a:stretch>
+        </p:blipFill>
+        <p:spPr>
+          <a:xfrm>
+            <a:off x="5852160" y="3749039"/>
+            <a:ext cx="6126480" cy="2834640"/>
+          </a:xfrm>
+          <a:prstGeom prst="rect">
+            <a:avLst/>
+          </a:prstGeom>
+        </p:spPr>
+      </p:pic>
     </p:spTree>
     <p:extLst>
       <p:ext uri="{BB962C8B-B14F-4D97-AF65-F5344CB8AC3E}">

</xml_diff>